<commit_message>
Make entity the unit of knowledge; summary becomes a flavour
Entity is standalone and shown as a card; a summary is an entity with
underlying artifacts. Spec, dictionary, database tables and deck
updated; summary-types.tsv renamed to entity-types.tsv. Adds the
untracked plan, diagrams and designs.

Co-Authored-By: Claude Fable 5.1 <noreply@anthropic.com>
</commit_message>
<xml_diff>
--- a/harness-diagram.pptx
+++ b/harness-diagram.pptx
@@ -1170,7 +1170,7 @@
                 <a:ea typeface="Calibri" pitchFamily="34" charset="-122"/>
                 <a:cs typeface="Calibri" pitchFamily="34" charset="-120"/>
               </a:rPr>
-              <a:t>Summaries</a:t>
+              <a:t>Entities</a:t>
             </a:r>
             <a:endParaRPr lang="en-US" sz="1000" dirty="0"/>
           </a:p>
@@ -1310,7 +1310,7 @@
                 <a:ea typeface="Calibri" pitchFamily="34" charset="-122"/>
                 <a:cs typeface="Calibri" pitchFamily="34" charset="-120"/>
               </a:rPr>
-              <a:t>Summary browsing</a:t>
+              <a:t>Entity browsing</a:t>
             </a:r>
             <a:endParaRPr lang="en-US" sz="1000" dirty="0"/>
           </a:p>
@@ -1327,7 +1327,7 @@
                 <a:ea typeface="Calibri" pitchFamily="34" charset="-122"/>
                 <a:cs typeface="Calibri" pitchFamily="34" charset="-120"/>
               </a:rPr>
-              <a:t>Summary search</a:t>
+              <a:t>Entity search</a:t>
             </a:r>
             <a:endParaRPr lang="en-US" sz="1000" dirty="0"/>
           </a:p>
@@ -2668,7 +2668,7 @@
                 <a:ea typeface="Calibri" pitchFamily="34" charset="-122"/>
                 <a:cs typeface="Calibri" pitchFamily="34" charset="-120"/>
               </a:rPr>
-              <a:t>Summary context</a:t>
+              <a:t>Entity context</a:t>
             </a:r>
             <a:endParaRPr lang="en-US" sz="1000" dirty="0"/>
           </a:p>
@@ -4068,7 +4068,7 @@
                 <a:ea typeface="Calibri" pitchFamily="34" charset="-122"/>
                 <a:cs typeface="Calibri" pitchFamily="34" charset="-120"/>
               </a:rPr>
-              <a:t>Summary Cards</a:t>
+              <a:t>Entity Cards</a:t>
             </a:r>
             <a:endParaRPr lang="en-US" sz="1050" dirty="0"/>
           </a:p>
@@ -5451,7 +5451,7 @@
                 <a:ea typeface="Calibri" pitchFamily="34" charset="-122"/>
                 <a:cs typeface="Calibri" pitchFamily="34" charset="-120"/>
               </a:rPr>
-              <a:t>Validates summary limits and references</a:t>
+              <a:t>Validates card limits and references</a:t>
             </a:r>
             <a:endParaRPr lang="en-US" sz="800" dirty="0"/>
           </a:p>
@@ -6188,7 +6188,7 @@
                 <a:ea typeface="Calibri" pitchFamily="34" charset="-122"/>
                 <a:cs typeface="Calibri" pitchFamily="34" charset="-120"/>
               </a:rPr>
-              <a:t>Summary cards</a:t>
+              <a:t>Entity cards</a:t>
             </a:r>
             <a:endParaRPr lang="en-US" sz="1000" dirty="0"/>
           </a:p>
@@ -7538,7 +7538,7 @@
                 <a:ea typeface="Calibri" pitchFamily="34" charset="-122"/>
                 <a:cs typeface="Calibri" pitchFamily="34" charset="-120"/>
               </a:rPr>
-              <a:t>Items are summaries of any type</a:t>
+              <a:t>Items are entities of any type</a:t>
             </a:r>
             <a:endParaRPr lang="en-US" sz="800" dirty="0"/>
           </a:p>

</xml_diff>